<commit_message>
update: add TOC + Prior Work slides to PPTX (30→32 slides)
Slide 2: Table of Contents (6 sections with color-coded boxes)
Slide 3: Prior Work — MOSD & MutClust side-by-side
  MOSD: composite metric + single-factor isolation design
  MutClust: H-score + adaptive DBSCAN, 3 limitations → MutBench motivation

Co-Authored-By: Claude Opus 4.6 (1M context) <noreply@anthropic.com>
</commit_message>
<xml_diff>
--- a/paper/ppt/MutBench_Defense.pptx
+++ b/paper/ppt/MutBench_Defense.pptx
@@ -6,6 +6,8 @@
   </p:sldMasterIdLst>
   <p:sldIdLst>
     <p:sldId id="256" r:id="rId7"/>
+    <p:sldId id="286" r:id="rId37"/>
+    <p:sldId id="287" r:id="rId38"/>
     <p:sldId id="257" r:id="rId8"/>
     <p:sldId id="258" r:id="rId9"/>
     <p:sldId id="259" r:id="rId10"/>
@@ -15595,6 +15597,1446 @@
 </p:sld>
 </file>
 
+<file path=ppt/slides/slide31.xml><?xml version="1.0" encoding="utf-8"?>
+<p:sld xmlns:a="http://schemas.openxmlformats.org/drawingml/2006/main" xmlns:p="http://schemas.openxmlformats.org/presentationml/2006/main" xmlns:r="http://schemas.openxmlformats.org/officeDocument/2006/relationships">
+  <p:cSld>
+    <p:spTree>
+      <p:nvGrpSpPr>
+        <p:cNvPr id="1" name=""/>
+        <p:cNvGrpSpPr/>
+        <p:nvPr/>
+      </p:nvGrpSpPr>
+      <p:grpSpPr/>
+      <p:sp>
+        <p:nvSpPr>
+          <p:cNvPr id="2" name="Rectangle 1"/>
+          <p:cNvSpPr/>
+          <p:nvPr/>
+        </p:nvSpPr>
+        <p:spPr>
+          <a:xfrm>
+            <a:off x="0" y="0"/>
+            <a:ext cx="12191695" cy="822960"/>
+          </a:xfrm>
+          <a:prstGeom prst="rect">
+            <a:avLst/>
+          </a:prstGeom>
+          <a:solidFill>
+            <a:srgbClr val="2C3E50"/>
+          </a:solidFill>
+          <a:ln>
+            <a:noFill/>
+          </a:ln>
+        </p:spPr>
+        <p:style>
+          <a:lnRef idx="1">
+            <a:schemeClr val="accent1"/>
+          </a:lnRef>
+          <a:fillRef idx="3">
+            <a:schemeClr val="accent1"/>
+          </a:fillRef>
+          <a:effectRef idx="2">
+            <a:schemeClr val="accent1"/>
+          </a:effectRef>
+          <a:fontRef idx="minor">
+            <a:schemeClr val="lt1"/>
+          </a:fontRef>
+        </p:style>
+        <p:txBody>
+          <a:bodyPr rtlCol="0" anchor="ctr"/>
+          <a:lstStyle/>
+          <a:p>
+            <a:pPr algn="ctr"/>
+          </a:p>
+        </p:txBody>
+      </p:sp>
+      <p:sp>
+        <p:nvSpPr>
+          <p:cNvPr id="3" name="TextBox 2"/>
+          <p:cNvSpPr txBox="1"/>
+          <p:nvPr/>
+        </p:nvSpPr>
+        <p:spPr>
+          <a:xfrm>
+            <a:off x="457200" y="137160"/>
+            <a:ext cx="10058400" cy="548640"/>
+          </a:xfrm>
+          <a:prstGeom prst="rect">
+            <a:avLst/>
+          </a:prstGeom>
+          <a:noFill/>
+        </p:spPr>
+        <p:txBody>
+          <a:bodyPr wrap="square">
+            <a:spAutoFit/>
+          </a:bodyPr>
+          <a:lstStyle/>
+          <a:p>
+            <a:pPr>
+              <a:defRPr sz="2800" b="1">
+                <a:solidFill>
+                  <a:srgbClr val="FFFFFF"/>
+                </a:solidFill>
+              </a:defRPr>
+            </a:pPr>
+            <a:r>
+              <a:t>Table of Contents</a:t>
+            </a:r>
+          </a:p>
+        </p:txBody>
+      </p:sp>
+      <p:sp>
+        <p:nvSpPr>
+          <p:cNvPr id="4" name="Rectangle 3"/>
+          <p:cNvSpPr/>
+          <p:nvPr/>
+        </p:nvSpPr>
+        <p:spPr>
+          <a:xfrm>
+            <a:off x="0" y="6537960"/>
+            <a:ext cx="12191695" cy="320040"/>
+          </a:xfrm>
+          <a:prstGeom prst="rect">
+            <a:avLst/>
+          </a:prstGeom>
+          <a:solidFill>
+            <a:srgbClr val="2C3E50"/>
+          </a:solidFill>
+          <a:ln>
+            <a:noFill/>
+          </a:ln>
+        </p:spPr>
+        <p:style>
+          <a:lnRef idx="1">
+            <a:schemeClr val="accent1"/>
+          </a:lnRef>
+          <a:fillRef idx="3">
+            <a:schemeClr val="accent1"/>
+          </a:fillRef>
+          <a:effectRef idx="2">
+            <a:schemeClr val="accent1"/>
+          </a:effectRef>
+          <a:fontRef idx="minor">
+            <a:schemeClr val="lt1"/>
+          </a:fontRef>
+        </p:style>
+        <p:txBody>
+          <a:bodyPr rtlCol="0" anchor="ctr"/>
+          <a:lstStyle/>
+          <a:p>
+            <a:pPr algn="ctr"/>
+          </a:p>
+        </p:txBody>
+      </p:sp>
+      <p:sp>
+        <p:nvSpPr>
+          <p:cNvPr id="5" name="TextBox 4"/>
+          <p:cNvSpPr txBox="1"/>
+          <p:nvPr/>
+        </p:nvSpPr>
+        <p:spPr>
+          <a:xfrm>
+            <a:off x="457200" y="6565392"/>
+            <a:ext cx="9144000" cy="274320"/>
+          </a:xfrm>
+          <a:prstGeom prst="rect">
+            <a:avLst/>
+          </a:prstGeom>
+          <a:noFill/>
+        </p:spPr>
+        <p:txBody>
+          <a:bodyPr wrap="none">
+            <a:spAutoFit/>
+          </a:bodyPr>
+          <a:lstStyle/>
+          <a:p>
+            <a:pPr>
+              <a:defRPr sz="1000">
+                <a:solidFill>
+                  <a:srgbClr val="FFFFFF"/>
+                </a:solidFill>
+              </a:defRPr>
+            </a:pPr>
+            <a:r>
+              <a:t>Kyungpook National University  |  Dept. of Computer Science  |  Hwijun Kwon</a:t>
+            </a:r>
+          </a:p>
+        </p:txBody>
+      </p:sp>
+      <p:sp>
+        <p:nvSpPr>
+          <p:cNvPr id="6" name="TextBox 5"/>
+          <p:cNvSpPr txBox="1"/>
+          <p:nvPr/>
+        </p:nvSpPr>
+        <p:spPr>
+          <a:xfrm>
+            <a:off x="11430000" y="6565392"/>
+            <a:ext cx="640080" cy="274320"/>
+          </a:xfrm>
+          <a:prstGeom prst="rect">
+            <a:avLst/>
+          </a:prstGeom>
+          <a:noFill/>
+        </p:spPr>
+        <p:txBody>
+          <a:bodyPr wrap="none">
+            <a:spAutoFit/>
+          </a:bodyPr>
+          <a:lstStyle/>
+          <a:p>
+            <a:pPr algn="r">
+              <a:defRPr sz="1000">
+                <a:solidFill>
+                  <a:srgbClr val="FFFFFF"/>
+                </a:solidFill>
+              </a:defRPr>
+            </a:pPr>
+            <a:r>
+              <a:t>2/32</a:t>
+            </a:r>
+          </a:p>
+        </p:txBody>
+      </p:sp>
+      <p:sp>
+        <p:nvSpPr>
+          <p:cNvPr id="7" name="Rounded Rectangle 6"/>
+          <p:cNvSpPr/>
+          <p:nvPr/>
+        </p:nvSpPr>
+        <p:spPr>
+          <a:xfrm>
+            <a:off x="457200" y="1188720"/>
+            <a:ext cx="3474720" cy="2103120"/>
+          </a:xfrm>
+          <a:prstGeom prst="roundRect">
+            <a:avLst/>
+          </a:prstGeom>
+          <a:solidFill>
+            <a:srgbClr val="2980B9"/>
+          </a:solidFill>
+          <a:ln>
+            <a:noFill/>
+          </a:ln>
+        </p:spPr>
+        <p:style>
+          <a:lnRef idx="1">
+            <a:schemeClr val="accent1"/>
+          </a:lnRef>
+          <a:fillRef idx="3">
+            <a:schemeClr val="accent1"/>
+          </a:fillRef>
+          <a:effectRef idx="2">
+            <a:schemeClr val="accent1"/>
+          </a:effectRef>
+          <a:fontRef idx="minor">
+            <a:schemeClr val="lt1"/>
+          </a:fontRef>
+        </p:style>
+        <p:txBody>
+          <a:bodyPr rtlCol="0" anchor="ctr"/>
+          <a:lstStyle/>
+          <a:p>
+            <a:pPr algn="ctr"/>
+          </a:p>
+        </p:txBody>
+      </p:sp>
+      <p:sp>
+        <p:nvSpPr>
+          <p:cNvPr id="8" name="TextBox 7"/>
+          <p:cNvSpPr txBox="1"/>
+          <p:nvPr/>
+        </p:nvSpPr>
+        <p:spPr>
+          <a:xfrm>
+            <a:off x="640080" y="1371600"/>
+            <a:ext cx="3108960" cy="1828800"/>
+          </a:xfrm>
+          <a:prstGeom prst="rect">
+            <a:avLst/>
+          </a:prstGeom>
+          <a:noFill/>
+        </p:spPr>
+        <p:txBody>
+          <a:bodyPr wrap="square">
+            <a:spAutoFit/>
+          </a:bodyPr>
+          <a:lstStyle/>
+          <a:p>
+            <a:pPr>
+              <a:defRPr sz="2200" b="1">
+                <a:solidFill>
+                  <a:srgbClr val="FFFFFF"/>
+                </a:solidFill>
+              </a:defRPr>
+            </a:pPr>
+            <a:r>
+              <a:t>I.  Introduction</a:t>
+            </a:r>
+          </a:p>
+          <a:p>
+            <a:pPr>
+              <a:spcBef>
+                <a:spcPts val="1200"/>
+              </a:spcBef>
+              <a:defRPr sz="1400">
+                <a:solidFill>
+                  <a:srgbClr val="DCDCDC"/>
+                </a:solidFill>
+              </a:defRPr>
+            </a:pPr>
+            <a:r>
+              <a:t>Background, Problem, Contributions</a:t>
+            </a:r>
+          </a:p>
+        </p:txBody>
+      </p:sp>
+      <p:sp>
+        <p:nvSpPr>
+          <p:cNvPr id="9" name="Rounded Rectangle 8"/>
+          <p:cNvSpPr/>
+          <p:nvPr/>
+        </p:nvSpPr>
+        <p:spPr>
+          <a:xfrm>
+            <a:off x="4297680" y="1188720"/>
+            <a:ext cx="3474720" cy="2103120"/>
+          </a:xfrm>
+          <a:prstGeom prst="roundRect">
+            <a:avLst/>
+          </a:prstGeom>
+          <a:solidFill>
+            <a:srgbClr val="27AE60"/>
+          </a:solidFill>
+          <a:ln>
+            <a:noFill/>
+          </a:ln>
+        </p:spPr>
+        <p:style>
+          <a:lnRef idx="1">
+            <a:schemeClr val="accent1"/>
+          </a:lnRef>
+          <a:fillRef idx="3">
+            <a:schemeClr val="accent1"/>
+          </a:fillRef>
+          <a:effectRef idx="2">
+            <a:schemeClr val="accent1"/>
+          </a:effectRef>
+          <a:fontRef idx="minor">
+            <a:schemeClr val="lt1"/>
+          </a:fontRef>
+        </p:style>
+        <p:txBody>
+          <a:bodyPr rtlCol="0" anchor="ctr"/>
+          <a:lstStyle/>
+          <a:p>
+            <a:pPr algn="ctr"/>
+          </a:p>
+        </p:txBody>
+      </p:sp>
+      <p:sp>
+        <p:nvSpPr>
+          <p:cNvPr id="10" name="TextBox 9"/>
+          <p:cNvSpPr txBox="1"/>
+          <p:nvPr/>
+        </p:nvSpPr>
+        <p:spPr>
+          <a:xfrm>
+            <a:off x="4480560" y="1371600"/>
+            <a:ext cx="3108960" cy="1828800"/>
+          </a:xfrm>
+          <a:prstGeom prst="rect">
+            <a:avLst/>
+          </a:prstGeom>
+          <a:noFill/>
+        </p:spPr>
+        <p:txBody>
+          <a:bodyPr wrap="square">
+            <a:spAutoFit/>
+          </a:bodyPr>
+          <a:lstStyle/>
+          <a:p>
+            <a:pPr>
+              <a:defRPr sz="2200" b="1">
+                <a:solidFill>
+                  <a:srgbClr val="FFFFFF"/>
+                </a:solidFill>
+              </a:defRPr>
+            </a:pPr>
+            <a:r>
+              <a:t>II.  MutBench Framework</a:t>
+            </a:r>
+          </a:p>
+          <a:p>
+            <a:pPr>
+              <a:spcBef>
+                <a:spcPts val="1200"/>
+              </a:spcBef>
+              <a:defRPr sz="1400">
+                <a:solidFill>
+                  <a:srgbClr val="DCDCDC"/>
+                </a:solidFill>
+              </a:defRPr>
+            </a:pPr>
+            <a:r>
+              <a:t>3-Layer GT, Hotspot-score, Pipeline</a:t>
+            </a:r>
+          </a:p>
+        </p:txBody>
+      </p:sp>
+      <p:sp>
+        <p:nvSpPr>
+          <p:cNvPr id="11" name="Rounded Rectangle 10"/>
+          <p:cNvSpPr/>
+          <p:nvPr/>
+        </p:nvSpPr>
+        <p:spPr>
+          <a:xfrm>
+            <a:off x="8138160" y="1188720"/>
+            <a:ext cx="3474720" cy="2103120"/>
+          </a:xfrm>
+          <a:prstGeom prst="roundRect">
+            <a:avLst/>
+          </a:prstGeom>
+          <a:solidFill>
+            <a:srgbClr val="2980B9"/>
+          </a:solidFill>
+          <a:ln>
+            <a:noFill/>
+          </a:ln>
+        </p:spPr>
+        <p:style>
+          <a:lnRef idx="1">
+            <a:schemeClr val="accent1"/>
+          </a:lnRef>
+          <a:fillRef idx="3">
+            <a:schemeClr val="accent1"/>
+          </a:fillRef>
+          <a:effectRef idx="2">
+            <a:schemeClr val="accent1"/>
+          </a:effectRef>
+          <a:fontRef idx="minor">
+            <a:schemeClr val="lt1"/>
+          </a:fontRef>
+        </p:style>
+        <p:txBody>
+          <a:bodyPr rtlCol="0" anchor="ctr"/>
+          <a:lstStyle/>
+          <a:p>
+            <a:pPr algn="ctr"/>
+          </a:p>
+        </p:txBody>
+      </p:sp>
+      <p:sp>
+        <p:nvSpPr>
+          <p:cNvPr id="12" name="TextBox 11"/>
+          <p:cNvSpPr txBox="1"/>
+          <p:nvPr/>
+        </p:nvSpPr>
+        <p:spPr>
+          <a:xfrm>
+            <a:off x="8321040" y="1371600"/>
+            <a:ext cx="3108960" cy="1828800"/>
+          </a:xfrm>
+          <a:prstGeom prst="rect">
+            <a:avLst/>
+          </a:prstGeom>
+          <a:noFill/>
+        </p:spPr>
+        <p:txBody>
+          <a:bodyPr wrap="square">
+            <a:spAutoFit/>
+          </a:bodyPr>
+          <a:lstStyle/>
+          <a:p>
+            <a:pPr>
+              <a:defRPr sz="2200" b="1">
+                <a:solidFill>
+                  <a:srgbClr val="FFFFFF"/>
+                </a:solidFill>
+              </a:defRPr>
+            </a:pPr>
+            <a:r>
+              <a:t>III.  Stage 1 Results</a:t>
+            </a:r>
+          </a:p>
+          <a:p>
+            <a:pPr>
+              <a:spcBef>
+                <a:spcPts val="1200"/>
+              </a:spcBef>
+              <a:defRPr sz="1400">
+                <a:solidFill>
+                  <a:srgbClr val="DCDCDC"/>
+                </a:solidFill>
+              </a:defRPr>
+            </a:pPr>
+            <a:r>
+              <a:t>SARS-CoV-2 Depth Analysis</a:t>
+            </a:r>
+          </a:p>
+        </p:txBody>
+      </p:sp>
+      <p:sp>
+        <p:nvSpPr>
+          <p:cNvPr id="13" name="Rounded Rectangle 12"/>
+          <p:cNvSpPr/>
+          <p:nvPr/>
+        </p:nvSpPr>
+        <p:spPr>
+          <a:xfrm>
+            <a:off x="457200" y="3749039"/>
+            <a:ext cx="3474720" cy="2103120"/>
+          </a:xfrm>
+          <a:prstGeom prst="roundRect">
+            <a:avLst/>
+          </a:prstGeom>
+          <a:solidFill>
+            <a:srgbClr val="E67E22"/>
+          </a:solidFill>
+          <a:ln>
+            <a:noFill/>
+          </a:ln>
+        </p:spPr>
+        <p:style>
+          <a:lnRef idx="1">
+            <a:schemeClr val="accent1"/>
+          </a:lnRef>
+          <a:fillRef idx="3">
+            <a:schemeClr val="accent1"/>
+          </a:fillRef>
+          <a:effectRef idx="2">
+            <a:schemeClr val="accent1"/>
+          </a:effectRef>
+          <a:fontRef idx="minor">
+            <a:schemeClr val="lt1"/>
+          </a:fontRef>
+        </p:style>
+        <p:txBody>
+          <a:bodyPr rtlCol="0" anchor="ctr"/>
+          <a:lstStyle/>
+          <a:p>
+            <a:pPr algn="ctr"/>
+          </a:p>
+        </p:txBody>
+      </p:sp>
+      <p:sp>
+        <p:nvSpPr>
+          <p:cNvPr id="14" name="TextBox 13"/>
+          <p:cNvSpPr txBox="1"/>
+          <p:nvPr/>
+        </p:nvSpPr>
+        <p:spPr>
+          <a:xfrm>
+            <a:off x="640080" y="3931919"/>
+            <a:ext cx="3108960" cy="1828800"/>
+          </a:xfrm>
+          <a:prstGeom prst="rect">
+            <a:avLst/>
+          </a:prstGeom>
+          <a:noFill/>
+        </p:spPr>
+        <p:txBody>
+          <a:bodyPr wrap="square">
+            <a:spAutoFit/>
+          </a:bodyPr>
+          <a:lstStyle/>
+          <a:p>
+            <a:pPr>
+              <a:defRPr sz="2200" b="1">
+                <a:solidFill>
+                  <a:srgbClr val="FFFFFF"/>
+                </a:solidFill>
+              </a:defRPr>
+            </a:pPr>
+            <a:r>
+              <a:t>IV.  Stage 2 Results</a:t>
+            </a:r>
+          </a:p>
+          <a:p>
+            <a:pPr>
+              <a:spcBef>
+                <a:spcPts val="1200"/>
+              </a:spcBef>
+              <a:defRPr sz="1400">
+                <a:solidFill>
+                  <a:srgbClr val="DCDCDC"/>
+                </a:solidFill>
+              </a:defRPr>
+            </a:pPr>
+            <a:r>
+              <a:t>9-Pathogen Benchmark, 4 Evidence Lines</a:t>
+            </a:r>
+          </a:p>
+        </p:txBody>
+      </p:sp>
+      <p:sp>
+        <p:nvSpPr>
+          <p:cNvPr id="15" name="Rounded Rectangle 14"/>
+          <p:cNvSpPr/>
+          <p:nvPr/>
+        </p:nvSpPr>
+        <p:spPr>
+          <a:xfrm>
+            <a:off x="4297680" y="3749039"/>
+            <a:ext cx="3474720" cy="2103120"/>
+          </a:xfrm>
+          <a:prstGeom prst="roundRect">
+            <a:avLst/>
+          </a:prstGeom>
+          <a:solidFill>
+            <a:srgbClr val="27AE60"/>
+          </a:solidFill>
+          <a:ln>
+            <a:noFill/>
+          </a:ln>
+        </p:spPr>
+        <p:style>
+          <a:lnRef idx="1">
+            <a:schemeClr val="accent1"/>
+          </a:lnRef>
+          <a:fillRef idx="3">
+            <a:schemeClr val="accent1"/>
+          </a:fillRef>
+          <a:effectRef idx="2">
+            <a:schemeClr val="accent1"/>
+          </a:effectRef>
+          <a:fontRef idx="minor">
+            <a:schemeClr val="lt1"/>
+          </a:fontRef>
+        </p:style>
+        <p:txBody>
+          <a:bodyPr rtlCol="0" anchor="ctr"/>
+          <a:lstStyle/>
+          <a:p>
+            <a:pPr algn="ctr"/>
+          </a:p>
+        </p:txBody>
+      </p:sp>
+      <p:sp>
+        <p:nvSpPr>
+          <p:cNvPr id="16" name="TextBox 15"/>
+          <p:cNvSpPr txBox="1"/>
+          <p:nvPr/>
+        </p:nvSpPr>
+        <p:spPr>
+          <a:xfrm>
+            <a:off x="4480560" y="3931919"/>
+            <a:ext cx="3108960" cy="1828800"/>
+          </a:xfrm>
+          <a:prstGeom prst="rect">
+            <a:avLst/>
+          </a:prstGeom>
+          <a:noFill/>
+        </p:spPr>
+        <p:txBody>
+          <a:bodyPr wrap="square">
+            <a:spAutoFit/>
+          </a:bodyPr>
+          <a:lstStyle/>
+          <a:p>
+            <a:pPr>
+              <a:defRPr sz="2200" b="1">
+                <a:solidFill>
+                  <a:srgbClr val="FFFFFF"/>
+                </a:solidFill>
+              </a:defRPr>
+            </a:pPr>
+            <a:r>
+              <a:t>V.  Extensions</a:t>
+            </a:r>
+          </a:p>
+          <a:p>
+            <a:pPr>
+              <a:spcBef>
+                <a:spcPts val="1200"/>
+              </a:spcBef>
+              <a:defRPr sz="1400">
+                <a:solidFill>
+                  <a:srgbClr val="DCDCDC"/>
+                </a:solidFill>
+              </a:defRPr>
+            </a:pPr>
+            <a:r>
+              <a:t>ESM-2, PAHD, Phylo Correction</a:t>
+            </a:r>
+          </a:p>
+        </p:txBody>
+      </p:sp>
+      <p:sp>
+        <p:nvSpPr>
+          <p:cNvPr id="17" name="Rounded Rectangle 16"/>
+          <p:cNvSpPr/>
+          <p:nvPr/>
+        </p:nvSpPr>
+        <p:spPr>
+          <a:xfrm>
+            <a:off x="8138160" y="3749039"/>
+            <a:ext cx="3474720" cy="2103120"/>
+          </a:xfrm>
+          <a:prstGeom prst="roundRect">
+            <a:avLst/>
+          </a:prstGeom>
+          <a:solidFill>
+            <a:srgbClr val="2C3E50"/>
+          </a:solidFill>
+          <a:ln>
+            <a:noFill/>
+          </a:ln>
+        </p:spPr>
+        <p:style>
+          <a:lnRef idx="1">
+            <a:schemeClr val="accent1"/>
+          </a:lnRef>
+          <a:fillRef idx="3">
+            <a:schemeClr val="accent1"/>
+          </a:fillRef>
+          <a:effectRef idx="2">
+            <a:schemeClr val="accent1"/>
+          </a:effectRef>
+          <a:fontRef idx="minor">
+            <a:schemeClr val="lt1"/>
+          </a:fontRef>
+        </p:style>
+        <p:txBody>
+          <a:bodyPr rtlCol="0" anchor="ctr"/>
+          <a:lstStyle/>
+          <a:p>
+            <a:pPr algn="ctr"/>
+          </a:p>
+        </p:txBody>
+      </p:sp>
+      <p:sp>
+        <p:nvSpPr>
+          <p:cNvPr id="18" name="TextBox 17"/>
+          <p:cNvSpPr txBox="1"/>
+          <p:nvPr/>
+        </p:nvSpPr>
+        <p:spPr>
+          <a:xfrm>
+            <a:off x="8321040" y="3931919"/>
+            <a:ext cx="3108960" cy="1828800"/>
+          </a:xfrm>
+          <a:prstGeom prst="rect">
+            <a:avLst/>
+          </a:prstGeom>
+          <a:noFill/>
+        </p:spPr>
+        <p:txBody>
+          <a:bodyPr wrap="square">
+            <a:spAutoFit/>
+          </a:bodyPr>
+          <a:lstStyle/>
+          <a:p>
+            <a:pPr>
+              <a:defRPr sz="2200" b="1">
+                <a:solidFill>
+                  <a:srgbClr val="FFFFFF"/>
+                </a:solidFill>
+              </a:defRPr>
+            </a:pPr>
+            <a:r>
+              <a:t>VI.  Conclusion</a:t>
+            </a:r>
+          </a:p>
+          <a:p>
+            <a:pPr>
+              <a:spcBef>
+                <a:spcPts val="1200"/>
+              </a:spcBef>
+              <a:defRPr sz="1400">
+                <a:solidFill>
+                  <a:srgbClr val="DCDCDC"/>
+                </a:solidFill>
+              </a:defRPr>
+            </a:pPr>
+            <a:r>
+              <a:t>Contributions, Limitations, Future Work</a:t>
+            </a:r>
+          </a:p>
+        </p:txBody>
+      </p:sp>
+    </p:spTree>
+  </p:cSld>
+  <p:clrMapOvr>
+    <a:masterClrMapping/>
+  </p:clrMapOvr>
+</p:sld>
+</file>
+
+<file path=ppt/slides/slide32.xml><?xml version="1.0" encoding="utf-8"?>
+<p:sld xmlns:a="http://schemas.openxmlformats.org/drawingml/2006/main" xmlns:p="http://schemas.openxmlformats.org/presentationml/2006/main" xmlns:r="http://schemas.openxmlformats.org/officeDocument/2006/relationships">
+  <p:cSld>
+    <p:spTree>
+      <p:nvGrpSpPr>
+        <p:cNvPr id="1" name=""/>
+        <p:cNvGrpSpPr/>
+        <p:nvPr/>
+      </p:nvGrpSpPr>
+      <p:grpSpPr/>
+      <p:sp>
+        <p:nvSpPr>
+          <p:cNvPr id="2" name="Rectangle 1"/>
+          <p:cNvSpPr/>
+          <p:nvPr/>
+        </p:nvSpPr>
+        <p:spPr>
+          <a:xfrm>
+            <a:off x="0" y="0"/>
+            <a:ext cx="12191695" cy="822960"/>
+          </a:xfrm>
+          <a:prstGeom prst="rect">
+            <a:avLst/>
+          </a:prstGeom>
+          <a:solidFill>
+            <a:srgbClr val="2C3E50"/>
+          </a:solidFill>
+          <a:ln>
+            <a:noFill/>
+          </a:ln>
+        </p:spPr>
+        <p:style>
+          <a:lnRef idx="1">
+            <a:schemeClr val="accent1"/>
+          </a:lnRef>
+          <a:fillRef idx="3">
+            <a:schemeClr val="accent1"/>
+          </a:fillRef>
+          <a:effectRef idx="2">
+            <a:schemeClr val="accent1"/>
+          </a:effectRef>
+          <a:fontRef idx="minor">
+            <a:schemeClr val="lt1"/>
+          </a:fontRef>
+        </p:style>
+        <p:txBody>
+          <a:bodyPr rtlCol="0" anchor="ctr"/>
+          <a:lstStyle/>
+          <a:p>
+            <a:pPr algn="ctr"/>
+          </a:p>
+        </p:txBody>
+      </p:sp>
+      <p:sp>
+        <p:nvSpPr>
+          <p:cNvPr id="3" name="TextBox 2"/>
+          <p:cNvSpPr txBox="1"/>
+          <p:nvPr/>
+        </p:nvSpPr>
+        <p:spPr>
+          <a:xfrm>
+            <a:off x="457200" y="137160"/>
+            <a:ext cx="10058400" cy="548640"/>
+          </a:xfrm>
+          <a:prstGeom prst="rect">
+            <a:avLst/>
+          </a:prstGeom>
+          <a:noFill/>
+        </p:spPr>
+        <p:txBody>
+          <a:bodyPr wrap="square">
+            <a:spAutoFit/>
+          </a:bodyPr>
+          <a:lstStyle/>
+          <a:p>
+            <a:pPr>
+              <a:defRPr sz="2800" b="1">
+                <a:solidFill>
+                  <a:srgbClr val="FFFFFF"/>
+                </a:solidFill>
+              </a:defRPr>
+            </a:pPr>
+            <a:r>
+              <a:t>Prior Work: MOSD &amp; MutClust</a:t>
+            </a:r>
+          </a:p>
+        </p:txBody>
+      </p:sp>
+      <p:sp>
+        <p:nvSpPr>
+          <p:cNvPr id="4" name="Rectangle 3"/>
+          <p:cNvSpPr/>
+          <p:nvPr/>
+        </p:nvSpPr>
+        <p:spPr>
+          <a:xfrm>
+            <a:off x="0" y="6537960"/>
+            <a:ext cx="12191695" cy="320040"/>
+          </a:xfrm>
+          <a:prstGeom prst="rect">
+            <a:avLst/>
+          </a:prstGeom>
+          <a:solidFill>
+            <a:srgbClr val="2C3E50"/>
+          </a:solidFill>
+          <a:ln>
+            <a:noFill/>
+          </a:ln>
+        </p:spPr>
+        <p:style>
+          <a:lnRef idx="1">
+            <a:schemeClr val="accent1"/>
+          </a:lnRef>
+          <a:fillRef idx="3">
+            <a:schemeClr val="accent1"/>
+          </a:fillRef>
+          <a:effectRef idx="2">
+            <a:schemeClr val="accent1"/>
+          </a:effectRef>
+          <a:fontRef idx="minor">
+            <a:schemeClr val="lt1"/>
+          </a:fontRef>
+        </p:style>
+        <p:txBody>
+          <a:bodyPr rtlCol="0" anchor="ctr"/>
+          <a:lstStyle/>
+          <a:p>
+            <a:pPr algn="ctr"/>
+          </a:p>
+        </p:txBody>
+      </p:sp>
+      <p:sp>
+        <p:nvSpPr>
+          <p:cNvPr id="5" name="TextBox 4"/>
+          <p:cNvSpPr txBox="1"/>
+          <p:nvPr/>
+        </p:nvSpPr>
+        <p:spPr>
+          <a:xfrm>
+            <a:off x="457200" y="6565392"/>
+            <a:ext cx="9144000" cy="274320"/>
+          </a:xfrm>
+          <a:prstGeom prst="rect">
+            <a:avLst/>
+          </a:prstGeom>
+          <a:noFill/>
+        </p:spPr>
+        <p:txBody>
+          <a:bodyPr wrap="none">
+            <a:spAutoFit/>
+          </a:bodyPr>
+          <a:lstStyle/>
+          <a:p>
+            <a:pPr>
+              <a:defRPr sz="1000">
+                <a:solidFill>
+                  <a:srgbClr val="FFFFFF"/>
+                </a:solidFill>
+              </a:defRPr>
+            </a:pPr>
+            <a:r>
+              <a:t>Kyungpook National University  |  Dept. of Computer Science  |  Hwijun Kwon</a:t>
+            </a:r>
+          </a:p>
+        </p:txBody>
+      </p:sp>
+      <p:sp>
+        <p:nvSpPr>
+          <p:cNvPr id="6" name="TextBox 5"/>
+          <p:cNvSpPr txBox="1"/>
+          <p:nvPr/>
+        </p:nvSpPr>
+        <p:spPr>
+          <a:xfrm>
+            <a:off x="11430000" y="6565392"/>
+            <a:ext cx="640080" cy="274320"/>
+          </a:xfrm>
+          <a:prstGeom prst="rect">
+            <a:avLst/>
+          </a:prstGeom>
+          <a:noFill/>
+        </p:spPr>
+        <p:txBody>
+          <a:bodyPr wrap="none">
+            <a:spAutoFit/>
+          </a:bodyPr>
+          <a:lstStyle/>
+          <a:p>
+            <a:pPr algn="r">
+              <a:defRPr sz="1000">
+                <a:solidFill>
+                  <a:srgbClr val="FFFFFF"/>
+                </a:solidFill>
+              </a:defRPr>
+            </a:pPr>
+            <a:r>
+              <a:t>3/32</a:t>
+            </a:r>
+          </a:p>
+        </p:txBody>
+      </p:sp>
+      <p:sp>
+        <p:nvSpPr>
+          <p:cNvPr id="7" name="Rounded Rectangle 6"/>
+          <p:cNvSpPr/>
+          <p:nvPr/>
+        </p:nvSpPr>
+        <p:spPr>
+          <a:xfrm>
+            <a:off x="457200" y="1097280"/>
+            <a:ext cx="5303520" cy="5029200"/>
+          </a:xfrm>
+          <a:prstGeom prst="roundRect">
+            <a:avLst/>
+          </a:prstGeom>
+          <a:solidFill>
+            <a:srgbClr val="D6EAF8"/>
+          </a:solidFill>
+          <a:ln>
+            <a:noFill/>
+          </a:ln>
+        </p:spPr>
+        <p:style>
+          <a:lnRef idx="1">
+            <a:schemeClr val="accent1"/>
+          </a:lnRef>
+          <a:fillRef idx="3">
+            <a:schemeClr val="accent1"/>
+          </a:fillRef>
+          <a:effectRef idx="2">
+            <a:schemeClr val="accent1"/>
+          </a:effectRef>
+          <a:fontRef idx="minor">
+            <a:schemeClr val="lt1"/>
+          </a:fontRef>
+        </p:style>
+        <p:txBody>
+          <a:bodyPr rtlCol="0" anchor="ctr"/>
+          <a:lstStyle/>
+          <a:p>
+            <a:pPr algn="ctr"/>
+          </a:p>
+        </p:txBody>
+      </p:sp>
+      <p:sp>
+        <p:nvSpPr>
+          <p:cNvPr id="8" name="TextBox 7"/>
+          <p:cNvSpPr txBox="1"/>
+          <p:nvPr/>
+        </p:nvSpPr>
+        <p:spPr>
+          <a:xfrm>
+            <a:off x="594360" y="1188720"/>
+            <a:ext cx="5029200" cy="4846320"/>
+          </a:xfrm>
+          <a:prstGeom prst="rect">
+            <a:avLst/>
+          </a:prstGeom>
+          <a:noFill/>
+        </p:spPr>
+        <p:txBody>
+          <a:bodyPr wrap="square">
+            <a:spAutoFit/>
+          </a:bodyPr>
+          <a:lstStyle/>
+          <a:p>
+            <a:pPr>
+              <a:defRPr sz="1600" b="1">
+                <a:solidFill>
+                  <a:srgbClr val="2980B9"/>
+                </a:solidFill>
+              </a:defRPr>
+            </a:pPr>
+            <a:r>
+              <a:t>MOSD (BMC Genomics 2025)</a:t>
+            </a:r>
+          </a:p>
+          <a:p>
+            <a:pPr>
+              <a:spcBef>
+                <a:spcPts val="400"/>
+              </a:spcBef>
+              <a:defRPr sz="1300">
+                <a:solidFill>
+                  <a:srgbClr val="333333"/>
+                </a:solidFill>
+              </a:defRPr>
+            </a:pPr>
+            <a:r>
+              <a:t>Multi-Omics Study Design Framework</a:t>
+            </a:r>
+          </a:p>
+          <a:p>
+            <a:pPr>
+              <a:spcBef>
+                <a:spcPts val="400"/>
+              </a:spcBef>
+              <a:defRPr sz="1300">
+                <a:solidFill>
+                  <a:srgbClr val="333333"/>
+                </a:solidFill>
+              </a:defRPr>
+            </a:pPr>
+          </a:p>
+          <a:p>
+            <a:pPr>
+              <a:spcBef>
+                <a:spcPts val="400"/>
+              </a:spcBef>
+              <a:defRPr sz="1300">
+                <a:solidFill>
+                  <a:srgbClr val="333333"/>
+                </a:solidFill>
+              </a:defRPr>
+            </a:pPr>
+            <a:r>
+              <a:t>• 10 MOI methods × 10 TCGA cancers</a:t>
+            </a:r>
+          </a:p>
+          <a:p>
+            <a:pPr>
+              <a:spcBef>
+                <a:spcPts val="400"/>
+              </a:spcBef>
+              <a:defRPr sz="1300">
+                <a:solidFill>
+                  <a:srgbClr val="333333"/>
+                </a:solidFill>
+              </a:defRPr>
+            </a:pPr>
+            <a:r>
+              <a:t>• Cluster-score: (ARI + NMI + F-measure) / 3</a:t>
+            </a:r>
+          </a:p>
+          <a:p>
+            <a:pPr>
+              <a:spcBef>
+                <a:spcPts val="400"/>
+              </a:spcBef>
+              <a:defRPr sz="1300">
+                <a:solidFill>
+                  <a:srgbClr val="333333"/>
+                </a:solidFill>
+              </a:defRPr>
+            </a:pPr>
+            <a:r>
+              <a:t>• Single-factor isolation design</a:t>
+            </a:r>
+          </a:p>
+          <a:p>
+            <a:pPr>
+              <a:spcBef>
+                <a:spcPts val="400"/>
+              </a:spcBef>
+              <a:defRPr sz="1300">
+                <a:solidFill>
+                  <a:srgbClr val="333333"/>
+                </a:solidFill>
+              </a:defRPr>
+            </a:pPr>
+            <a:r>
+              <a:t>• Key finding: study design &gt; algorithm choice</a:t>
+            </a:r>
+          </a:p>
+          <a:p>
+            <a:pPr>
+              <a:spcBef>
+                <a:spcPts val="400"/>
+              </a:spcBef>
+              <a:defRPr sz="1300">
+                <a:solidFill>
+                  <a:srgbClr val="333333"/>
+                </a:solidFill>
+              </a:defRPr>
+            </a:pPr>
+          </a:p>
+          <a:p>
+            <a:pPr>
+              <a:spcBef>
+                <a:spcPts val="400"/>
+              </a:spcBef>
+              <a:defRPr sz="1300">
+                <a:solidFill>
+                  <a:srgbClr val="333333"/>
+                </a:solidFill>
+              </a:defRPr>
+            </a:pPr>
+            <a:r>
+              <a:t>→ Design principles transferred to MutBench:</a:t>
+            </a:r>
+          </a:p>
+          <a:p>
+            <a:pPr>
+              <a:spcBef>
+                <a:spcPts val="400"/>
+              </a:spcBef>
+              <a:defRPr sz="1300">
+                <a:solidFill>
+                  <a:srgbClr val="333333"/>
+                </a:solidFill>
+              </a:defRPr>
+            </a:pPr>
+            <a:r>
+              <a:t>  composite metric + controlled evaluation</a:t>
+            </a:r>
+          </a:p>
+        </p:txBody>
+      </p:sp>
+      <p:sp>
+        <p:nvSpPr>
+          <p:cNvPr id="9" name="Rounded Rectangle 8"/>
+          <p:cNvSpPr/>
+          <p:nvPr/>
+        </p:nvSpPr>
+        <p:spPr>
+          <a:xfrm>
+            <a:off x="6217920" y="1097280"/>
+            <a:ext cx="5303520" cy="5029200"/>
+          </a:xfrm>
+          <a:prstGeom prst="roundRect">
+            <a:avLst/>
+          </a:prstGeom>
+          <a:solidFill>
+            <a:srgbClr val="FDEBD0"/>
+          </a:solidFill>
+          <a:ln>
+            <a:noFill/>
+          </a:ln>
+        </p:spPr>
+        <p:style>
+          <a:lnRef idx="1">
+            <a:schemeClr val="accent1"/>
+          </a:lnRef>
+          <a:fillRef idx="3">
+            <a:schemeClr val="accent1"/>
+          </a:fillRef>
+          <a:effectRef idx="2">
+            <a:schemeClr val="accent1"/>
+          </a:effectRef>
+          <a:fontRef idx="minor">
+            <a:schemeClr val="lt1"/>
+          </a:fontRef>
+        </p:style>
+        <p:txBody>
+          <a:bodyPr rtlCol="0" anchor="ctr"/>
+          <a:lstStyle/>
+          <a:p>
+            <a:pPr algn="ctr"/>
+          </a:p>
+        </p:txBody>
+      </p:sp>
+      <p:sp>
+        <p:nvSpPr>
+          <p:cNvPr id="10" name="TextBox 9"/>
+          <p:cNvSpPr txBox="1"/>
+          <p:nvPr/>
+        </p:nvSpPr>
+        <p:spPr>
+          <a:xfrm>
+            <a:off x="6355080" y="1188720"/>
+            <a:ext cx="5029200" cy="4846320"/>
+          </a:xfrm>
+          <a:prstGeom prst="rect">
+            <a:avLst/>
+          </a:prstGeom>
+          <a:noFill/>
+        </p:spPr>
+        <p:txBody>
+          <a:bodyPr wrap="square">
+            <a:spAutoFit/>
+          </a:bodyPr>
+          <a:lstStyle/>
+          <a:p>
+            <a:pPr>
+              <a:defRPr sz="1600" b="1">
+                <a:solidFill>
+                  <a:srgbClr val="E67E22"/>
+                </a:solidFill>
+              </a:defRPr>
+            </a:pPr>
+            <a:r>
+              <a:t>MutClust (BioData Mining 2025)</a:t>
+            </a:r>
+          </a:p>
+          <a:p>
+            <a:pPr>
+              <a:spcBef>
+                <a:spcPts val="400"/>
+              </a:spcBef>
+              <a:defRPr sz="1300">
+                <a:solidFill>
+                  <a:srgbClr val="333333"/>
+                </a:solidFill>
+              </a:defRPr>
+            </a:pPr>
+            <a:r>
+              <a:t>Adaptive Density-Based Hotspot Detection</a:t>
+            </a:r>
+          </a:p>
+          <a:p>
+            <a:pPr>
+              <a:spcBef>
+                <a:spcPts val="400"/>
+              </a:spcBef>
+              <a:defRPr sz="1300">
+                <a:solidFill>
+                  <a:srgbClr val="333333"/>
+                </a:solidFill>
+              </a:defRPr>
+            </a:pPr>
+          </a:p>
+          <a:p>
+            <a:pPr>
+              <a:spcBef>
+                <a:spcPts val="400"/>
+              </a:spcBef>
+              <a:defRPr sz="1300">
+                <a:solidFill>
+                  <a:srgbClr val="333333"/>
+                </a:solidFill>
+              </a:defRPr>
+            </a:pPr>
+            <a:r>
+              <a:t>• H-score = log₂(frequency × entropy × 100 + 1)</a:t>
+            </a:r>
+          </a:p>
+          <a:p>
+            <a:pPr>
+              <a:spcBef>
+                <a:spcPts val="400"/>
+              </a:spcBef>
+              <a:defRPr sz="1300">
+                <a:solidFill>
+                  <a:srgbClr val="333333"/>
+                </a:solidFill>
+              </a:defRPr>
+            </a:pPr>
+            <a:r>
+              <a:t>• CCM seed detection + adaptive DBSCAN</a:t>
+            </a:r>
+          </a:p>
+          <a:p>
+            <a:pPr>
+              <a:spcBef>
+                <a:spcPts val="400"/>
+              </a:spcBef>
+              <a:defRPr sz="1300">
+                <a:solidFill>
+                  <a:srgbClr val="333333"/>
+                </a:solidFill>
+              </a:defRPr>
+            </a:pPr>
+            <a:r>
+              <a:t>• 477 hotspots in SARS-CoV-2 Spike</a:t>
+            </a:r>
+          </a:p>
+          <a:p>
+            <a:pPr>
+              <a:spcBef>
+                <a:spcPts val="400"/>
+              </a:spcBef>
+              <a:defRPr sz="1300">
+                <a:solidFill>
+                  <a:srgbClr val="333333"/>
+                </a:solidFill>
+              </a:defRPr>
+            </a:pPr>
+          </a:p>
+          <a:p>
+            <a:pPr>
+              <a:spcBef>
+                <a:spcPts val="400"/>
+              </a:spcBef>
+              <a:defRPr sz="1300">
+                <a:solidFill>
+                  <a:srgbClr val="333333"/>
+                </a:solidFill>
+              </a:defRPr>
+            </a:pPr>
+            <a:r>
+              <a:t>Limitations motivating MutBench:</a:t>
+            </a:r>
+          </a:p>
+          <a:p>
+            <a:pPr>
+              <a:spcBef>
+                <a:spcPts val="400"/>
+              </a:spcBef>
+              <a:defRPr sz="1300">
+                <a:solidFill>
+                  <a:srgbClr val="333333"/>
+                </a:solidFill>
+              </a:defRPr>
+            </a:pPr>
+            <a:r>
+              <a:t>  1. Implementation bug (cumulative decay)</a:t>
+            </a:r>
+          </a:p>
+          <a:p>
+            <a:pPr>
+              <a:spcBef>
+                <a:spcPts val="400"/>
+              </a:spcBef>
+              <a:defRPr sz="1300">
+                <a:solidFill>
+                  <a:srgbClr val="333333"/>
+                </a:solidFill>
+              </a:defRPr>
+            </a:pPr>
+            <a:r>
+              <a:t>  2. Parameters tuned for SARS-CoV-2 only</a:t>
+            </a:r>
+          </a:p>
+          <a:p>
+            <a:pPr>
+              <a:spcBef>
+                <a:spcPts val="400"/>
+              </a:spcBef>
+              <a:defRPr sz="1300">
+                <a:solidFill>
+                  <a:srgbClr val="333333"/>
+                </a:solidFill>
+              </a:defRPr>
+            </a:pPr>
+            <a:r>
+              <a:t>  3. No independent ground truth evaluation</a:t>
+            </a:r>
+          </a:p>
+        </p:txBody>
+      </p:sp>
+      <p:sp>
+        <p:nvSpPr>
+          <p:cNvPr id="11" name="TextBox 10"/>
+          <p:cNvSpPr txBox="1"/>
+          <p:nvPr/>
+        </p:nvSpPr>
+        <p:spPr>
+          <a:xfrm>
+            <a:off x="5029200" y="5486400"/>
+            <a:ext cx="2286000" cy="457200"/>
+          </a:xfrm>
+          <a:prstGeom prst="rect">
+            <a:avLst/>
+          </a:prstGeom>
+          <a:noFill/>
+        </p:spPr>
+        <p:txBody>
+          <a:bodyPr wrap="none">
+            <a:spAutoFit/>
+          </a:bodyPr>
+          <a:lstStyle/>
+          <a:p>
+            <a:pPr algn="ctr">
+              <a:defRPr sz="1400" b="1">
+                <a:solidFill>
+                  <a:srgbClr val="2C3E50"/>
+                </a:solidFill>
+              </a:defRPr>
+            </a:pPr>
+            <a:r>
+              <a:t>→ MutBench fills these gaps ←</a:t>
+            </a:r>
+          </a:p>
+        </p:txBody>
+      </p:sp>
+    </p:spTree>
+  </p:cSld>
+  <p:clrMapOvr>
+    <a:masterClrMapping/>
+  </p:clrMapOvr>
+</p:sld>
+</file>
+
 <file path=ppt/slides/slide4.xml><?xml version="1.0" encoding="utf-8"?>
 <p:sld xmlns:a="http://schemas.openxmlformats.org/drawingml/2006/main" xmlns:p="http://schemas.openxmlformats.org/presentationml/2006/main" xmlns:r="http://schemas.openxmlformats.org/officeDocument/2006/relationships">
   <p:cSld>

</xml_diff>